<commit_message>
fix(file-plugin): harden embedded extractors
</commit_message>
<xml_diff>
--- a/test-fixtures/ingestion/files/sample.pptx
+++ b/test-fixtures/ingestion/files/sample.pptx
@@ -1,13 +1,40 @@
+
+<file path=ppt/presentation.xml><?xml version="1.0" encoding="utf-8"?>
+<p:presentation xmlns:a="http://schemas.openxmlformats.org/drawingml/2006/main" xmlns:r="http://schemas.openxmlformats.org/officeDocument/2006/relationships" xmlns:p="http://schemas.openxmlformats.org/presentationml/2006/main">
+  <p:sldIdLst>
+    <p:sldId id="256" r:id="rId1"/>
+  </p:sldIdLst>
+  <p:sldSz cx="9144000" cy="6858000" type="screen4x3"/>
+  <p:notesSz cx="6858000" cy="9144000"/>
+</p:presentation>
+</file>
 
 <file path=ppt/slides/slide1.xml><?xml version="1.0" encoding="utf-8"?>
-<p:sld xmlns:p="http://schemas.openxmlformats.org/presentationml/2006/main" xmlns:a="http://schemas.openxmlformats.org/drawingml/2006/main">
+<p:sld xmlns:a="http://schemas.openxmlformats.org/drawingml/2006/main" xmlns:r="http://schemas.openxmlformats.org/officeDocument/2006/relationships" xmlns:p="http://schemas.openxmlformats.org/presentationml/2006/main">
   <p:cSld>
     <p:spTree>
+      <p:nvGrpSpPr>
+        <p:cNvPr id="1" name=""/>
+        <p:cNvGrpSpPr/>
+        <p:nvPr/>
+      </p:nvGrpSpPr>
+      <p:grpSpPr/>
       <p:sp>
+        <p:nvSpPr>
+          <p:cNvPr id="2" name="Text"/>
+          <p:cNvSpPr/>
+          <p:nvPr/>
+        </p:nvSpPr>
+        <p:spPr/>
         <p:txBody>
+          <a:bodyPr/>
+          <a:lstStyle/>
           <a:p>
             <a:r>
-              <a:t>PPTX fixture</a:t>
+              <a:t>PPTX </a:t>
+            </a:r>
+            <a:r>
+              <a:t>fixture</a:t>
             </a:r>
           </a:p>
           <a:p>
@@ -19,5 +46,8 @@
       </p:sp>
     </p:spTree>
   </p:cSld>
+  <p:clrMapOvr>
+    <a:masterClrMapping/>
+  </p:clrMapOvr>
 </p:sld>
 </file>
</xml_diff>